<commit_message>
refactor(presentation): incorporar semaforo de 3 estados (verde, amarillo, rojo) y eliminar todos los demas emojis
</commit_message>
<xml_diff>
--- a/Presentacion_Celulas_Innovacion_CDA.pptx
+++ b/Presentacion_Celulas_Innovacion_CDA.pptx
@@ -4008,7 +4008,7 @@
               </a:defRPr>
             </a:pPr>
             <a:r>
-              <a:t>🚗 PRODUCTO 01: Venta y Canales</a:t>
+              <a:t>PRODUCTO 01: Venta y Canales</a:t>
             </a:r>
           </a:p>
           <a:p>
@@ -4186,7 +4186,7 @@
               </a:defRPr>
             </a:pPr>
             <a:r>
-              <a:t>⏱️ Tiempo de Atención: De 20 min a 90 seg  |  +40% Captura de Prospectos</a:t>
+              <a:t>Tiempo de Atención: De 20 min a 90 seg  |  +40% Captura de Prospectos</a:t>
             </a:r>
           </a:p>
         </p:txBody>
@@ -4285,7 +4285,7 @@
               </a:defRPr>
             </a:pPr>
             <a:r>
-              <a:t>📄 PRODUCTO 02: Operaciones y Eficiencia</a:t>
+              <a:t>PRODUCTO 02: Operaciones y Eficiencia</a:t>
             </a:r>
           </a:p>
           <a:p>
@@ -4355,7 +4355,7 @@
               </a:defRPr>
             </a:pPr>
             <a:r>
-              <a:t>• Auditoría &amp; Semáforo: </a:t>
+              <a:t>• Auditoría y Semáforo: </a:t>
             </a:r>
             <a:r>
               <a:rPr b="0" sz="1000">
@@ -4463,7 +4463,7 @@
               </a:defRPr>
             </a:pPr>
             <a:r>
-              <a:t>⚡ Reducción Operativa: De 60 min a 2 min por préstamo  |  0% Error en Core IBS</a:t>
+              <a:t>Reducción Operativa: De 60 min a 2 min por préstamo  |  0% Error en Core IBS</a:t>
             </a:r>
           </a:p>
         </p:txBody>
@@ -4823,7 +4823,7 @@
               </a:defRPr>
             </a:pPr>
             <a:r>
-              <a:t>⚠️ La Fricción Operativa Actual en Ferias</a:t>
+              <a:t>La Fricción Operativa Actual en Ferias</a:t>
             </a:r>
           </a:p>
         </p:txBody>
@@ -5015,7 +5015,7 @@
               </a:defRPr>
             </a:pPr>
             <a:r>
-              <a:t>💡 La Propuesta de Valor del Asesor Virtual</a:t>
+              <a:t>La Propuesta de Valor del Asesor Virtual</a:t>
             </a:r>
           </a:p>
         </p:txBody>
@@ -5050,7 +5050,7 @@
               </a:defRPr>
             </a:pPr>
             <a:r>
-              <a:t>✔ Atención Simultánea e Ilimitada: </a:t>
+              <a:t>• Atención Simultánea e Ilimitada: </a:t>
             </a:r>
             <a:r>
               <a:rPr b="0" sz="1000">
@@ -5073,7 +5073,7 @@
               </a:defRPr>
             </a:pPr>
             <a:r>
-              <a:t>✔ Calificación Inteligente en 90 Segundos: </a:t>
+              <a:t>• Calificación Inteligente en 90 Segundos: </a:t>
             </a:r>
             <a:r>
               <a:rPr b="0" sz="1000">
@@ -5096,7 +5096,7 @@
               </a:defRPr>
             </a:pPr>
             <a:r>
-              <a:t>✔ Simulación Visual y Transparente: </a:t>
+              <a:t>• Simulación Visual y Transparente: </a:t>
             </a:r>
             <a:r>
               <a:rPr b="0" sz="1000">
@@ -5119,7 +5119,7 @@
               </a:defRPr>
             </a:pPr>
             <a:r>
-              <a:t>✔ Cierre Asistido para el Ejecutivo: </a:t>
+              <a:t>• Cierre Asistido para el Ejecutivo: </a:t>
             </a:r>
             <a:r>
               <a:rPr b="0" sz="1000">
@@ -5576,7 +5576,7 @@
               </a:defRPr>
             </a:pPr>
             <a:r>
-              <a:t>👋 Bienvenida y Prospección</a:t>
+              <a:t>Bienvenida y Prospección</a:t>
             </a:r>
           </a:p>
         </p:txBody>
@@ -5833,7 +5833,7 @@
               </a:defRPr>
             </a:pPr>
             <a:r>
-              <a:t>📋 Filtro de Política CDA</a:t>
+              <a:t>Filtro de Política CDA</a:t>
             </a:r>
           </a:p>
         </p:txBody>
@@ -6090,7 +6090,7 @@
               </a:defRPr>
             </a:pPr>
             <a:r>
-              <a:t>🧮 Simulación de Cuota</a:t>
+              <a:t>Simulación de Cuota</a:t>
             </a:r>
           </a:p>
         </p:txBody>
@@ -6347,7 +6347,7 @@
               </a:defRPr>
             </a:pPr>
             <a:r>
-              <a:t>🎯 Captura y Cierre</a:t>
+              <a:t>Captura y Cierre</a:t>
             </a:r>
           </a:p>
         </p:txBody>
@@ -6481,7 +6481,7 @@
               </a:defRPr>
             </a:pPr>
             <a:r>
-              <a:t>🚀 Impacto Operativo para el Banco: Reduce el tiempo de cotización de 20 minutos a 90 segundos. El ejecutivo del stand recibe un prospecto 100% calificado según política, eliminando clientes fuera de perfil y cerrando ventas en el acto.</a:t>
+              <a:t>Impacto Operativo para el Banco: Reduce el tiempo de cotización de 20 minutos a 90 segundos. El ejecutivo del stand recibe un prospecto 100% calificado según política, eliminando clientes fuera de perfil y cerrando ventas en el acto.</a:t>
             </a:r>
           </a:p>
         </p:txBody>
@@ -6895,7 +6895,7 @@
               </a:defRPr>
             </a:pPr>
             <a:r>
-              <a:t>🔴 Stopper 01: Certificado CSS</a:t>
+              <a:t>Stopper 01: Certificado CSS</a:t>
             </a:r>
           </a:p>
         </p:txBody>
@@ -7038,7 +7038,7 @@
               </a:defRPr>
             </a:pPr>
             <a:r>
-              <a:t>⏱️ Demora: 7 a 20 días hábiles en CSS</a:t>
+              <a:t>Demora: 7 a 20 días hábiles en CSS</a:t>
             </a:r>
           </a:p>
         </p:txBody>
@@ -7137,7 +7137,7 @@
               </a:defRPr>
             </a:pPr>
             <a:r>
-              <a:t>🟡 Stopper 02: Transcripción Manual</a:t>
+              <a:t>Stopper 02: Transcripción Manual</a:t>
             </a:r>
           </a:p>
         </p:txBody>
@@ -7280,7 +7280,7 @@
               </a:defRPr>
             </a:pPr>
             <a:r>
-              <a:t>⚠️ Riesgo: Errores tipográficos rechazan en IBS</a:t>
+              <a:t>Riesgo: Errores tipográficos rechazan en IBS</a:t>
             </a:r>
           </a:p>
         </p:txBody>
@@ -7379,7 +7379,7 @@
               </a:defRPr>
             </a:pPr>
             <a:r>
-              <a:t>🔵 Stopper 03: Compra de Saldo</a:t>
+              <a:t>Stopper 03: Compra de Saldo</a:t>
             </a:r>
           </a:p>
         </p:txBody>
@@ -7522,7 +7522,7 @@
               </a:defRPr>
             </a:pPr>
             <a:r>
-              <a:t>⏳ Carga: 20 a 35 min redactando en Word</a:t>
+              <a:t>Carga: 20 a 35 min redactando en Word</a:t>
             </a:r>
           </a:p>
         </p:txBody>
@@ -7936,7 +7936,7 @@
               </a:defRPr>
             </a:pPr>
             <a:r>
-              <a:t>🚫 Cero Acceso a Ultimus BPM</a:t>
+              <a:t>Cero Acceso a Ultimus BPM</a:t>
             </a:r>
           </a:p>
         </p:txBody>
@@ -8070,7 +8070,7 @@
               </a:defRPr>
             </a:pPr>
             <a:r>
-              <a:t>🛡️ Cero Conexión al Core IBS</a:t>
+              <a:t>Cero Conexión al Core IBS</a:t>
             </a:r>
           </a:p>
         </p:txBody>
@@ -8204,7 +8204,7 @@
               </a:defRPr>
             </a:pPr>
             <a:r>
-              <a:t>⚡ Cero VPN ni Permisos de Red</a:t>
+              <a:t>Cero VPN ni Permisos de Red</a:t>
             </a:r>
           </a:p>
         </p:txBody>
@@ -8338,7 +8338,7 @@
               </a:defRPr>
             </a:pPr>
             <a:r>
-              <a:t>👤 Control Humano (Human-in-the-Loop)</a:t>
+              <a:t>Control Humano (Human-in-the-Loop)</a:t>
             </a:r>
           </a:p>
         </p:txBody>
@@ -8427,7 +8427,7 @@
               </a:defRPr>
             </a:pPr>
             <a:r>
-              <a:t>🎯 Conclusión para Negocio y Ciberseguridad: Se puede desplegar y probar en días sin riesgo operativo ni auditorías de red complejas.</a:t>
+              <a:t>Conclusión para Negocio y Ciberseguridad: Se puede desplegar y probar en días sin riesgo operativo ni auditorías de red complejas.</a:t>
             </a:r>
           </a:p>
         </p:txBody>
@@ -8720,7 +8720,7 @@
         </p:nvSpPr>
         <p:spPr>
           <a:xfrm>
-            <a:off x="548640" y="1188720"/>
+            <a:off x="548640" y="1143000"/>
             <a:ext cx="11094415" cy="411480"/>
           </a:xfrm>
           <a:prstGeom prst="rect">
@@ -8735,7 +8735,7 @@
           <a:lstStyle/>
           <a:p>
             <a:pPr>
-              <a:defRPr sz="1200">
+              <a:defRPr sz="1150">
                 <a:solidFill>
                   <a:srgbClr val="0F2240"/>
                 </a:solidFill>
@@ -8755,8 +8755,8 @@
         </p:nvSpPr>
         <p:spPr>
           <a:xfrm>
-            <a:off x="548640" y="1691640"/>
-            <a:ext cx="3474720" cy="4663440"/>
+            <a:off x="548640" y="1627632"/>
+            <a:ext cx="3474720" cy="4754880"/>
           </a:xfrm>
           <a:prstGeom prst="roundRect">
             <a:avLst/>
@@ -8800,7 +8800,7 @@
         </p:nvSpPr>
         <p:spPr>
           <a:xfrm>
-            <a:off x="548640" y="1691640"/>
+            <a:off x="548640" y="1627632"/>
             <a:ext cx="3474720" cy="502920"/>
           </a:xfrm>
           <a:prstGeom prst="rect">
@@ -8866,8 +8866,8 @@
         </p:nvSpPr>
         <p:spPr>
           <a:xfrm>
-            <a:off x="685800" y="2286000"/>
-            <a:ext cx="3200400" cy="3474720"/>
+            <a:off x="685800" y="2194560"/>
+            <a:ext cx="3200400" cy="3611880"/>
           </a:xfrm>
           <a:prstGeom prst="rect">
             <a:avLst/>
@@ -8881,7 +8881,7 @@
           <a:lstStyle/>
           <a:p>
             <a:pPr>
-              <a:defRPr b="1" sz="950">
+              <a:defRPr b="1" sz="900">
                 <a:solidFill>
                   <a:srgbClr val="16A34A"/>
                 </a:solidFill>
@@ -8891,20 +8891,20 @@
               <a:t>Insumo: </a:t>
             </a:r>
             <a:r>
-              <a:rPr b="0" sz="900">
+              <a:rPr b="0" sz="850">
                 <a:solidFill>
                   <a:srgbClr val="0F2240"/>
                 </a:solidFill>
               </a:rPr>
-              <a:t>Expediente digital del cliente (PDFs).</a:t>
+              <a:t>Expediente digital del cliente (PDFs de cédula, carta y talonario).</a:t>
             </a:r>
           </a:p>
           <a:p>
             <a:pPr>
               <a:spcBef>
-                <a:spcPts val="500"/>
+                <a:spcPts val="400"/>
               </a:spcBef>
-              <a:defRPr b="1" sz="950">
+              <a:defRPr b="1" sz="900">
                 <a:solidFill>
                   <a:srgbClr val="16A34A"/>
                 </a:solidFill>
@@ -8914,66 +8914,112 @@
               <a:t>Qué hace la IA: </a:t>
             </a:r>
             <a:r>
-              <a:rPr b="0" sz="900">
+              <a:rPr b="0" sz="850">
                 <a:solidFill>
                   <a:srgbClr val="0F2240"/>
                 </a:solidFill>
               </a:rPr>
-              <a:t>Inspecciona cédula, carta de trabajo y talonario. Comprueba identidad cruzada y vigencia &lt; 30 días.</a:t>
+              <a:t>Inspecciona identidad cruzada, vigencias (&lt;30 días) y calendarios (no descuento en diciembre).</a:t>
             </a:r>
           </a:p>
           <a:p>
             <a:pPr>
               <a:spcBef>
-                <a:spcPts val="500"/>
+                <a:spcPts val="400"/>
               </a:spcBef>
-              <a:defRPr b="1" sz="950">
+              <a:defRPr b="1" sz="900">
                 <a:solidFill>
                   <a:srgbClr val="16A34A"/>
                 </a:solidFill>
               </a:defRPr>
             </a:pPr>
             <a:r>
-              <a:t>Regla de Jubilado: </a:t>
-            </a:r>
-            <a:r>
-              <a:rPr b="0" sz="900">
+              <a:t>Dictamen Semafórico: </a:t>
+            </a:r>
+            <a:r>
+              <a:rPr b="0" sz="850">
                 <a:solidFill>
                   <a:srgbClr val="0F2240"/>
                 </a:solidFill>
               </a:rPr>
-              <a:t>Si falta el Certificado de Jubilación de la CSS, emite 🔴 Semáforo Rojo de inmediato, devolviendo a sucursal y evitando retener el caso.</a:t>
+              <a:t>Clasifica en 3 estados normativos:</a:t>
             </a:r>
           </a:p>
           <a:p>
             <a:pPr>
               <a:spcBef>
-                <a:spcPts val="500"/>
+                <a:spcPts val="400"/>
               </a:spcBef>
-              <a:defRPr b="1" sz="950">
-                <a:solidFill>
-                  <a:srgbClr val="16A34A"/>
-                </a:solidFill>
-              </a:defRPr>
-            </a:pPr>
-            <a:r>
-              <a:t>Regla de Fechas: </a:t>
-            </a:r>
-            <a:r>
-              <a:rPr b="0" sz="900">
+              <a:defRPr b="1" sz="900">
                 <a:solidFill>
                   <a:srgbClr val="0F2240"/>
                 </a:solidFill>
+              </a:defRPr>
+            </a:pPr>
+            <a:r>
+              <a:t>• 🟢 Verde (Conforme): </a:t>
+            </a:r>
+            <a:r>
+              <a:rPr b="0" sz="850">
+                <a:solidFill>
+                  <a:srgbClr val="0F2240"/>
+                </a:solidFill>
               </a:rPr>
-              <a:t>Aplica calendario de descuentos y la regla: 'en diciembre no se descuenta préstamo personal'.</a:t>
+              <a:t>Expediente consistente y vigente; listo para formalizar.</a:t>
             </a:r>
           </a:p>
           <a:p>
             <a:pPr>
               <a:spcBef>
-                <a:spcPts val="500"/>
+                <a:spcPts val="400"/>
               </a:spcBef>
-              <a:defRPr b="1" sz="950">
+              <a:defRPr b="1" sz="900">
+                <a:solidFill>
+                  <a:srgbClr val="0F2240"/>
+                </a:solidFill>
+              </a:defRPr>
+            </a:pPr>
+            <a:r>
+              <a:t>• 🟡 Amarillo (Alerta): </a:t>
+            </a:r>
+            <a:r>
+              <a:rPr b="0" sz="850">
+                <a:solidFill>
+                  <a:srgbClr val="0F2240"/>
+                </a:solidFill>
+              </a:rPr>
+              <a:t>Vencimiento cercano (&lt;48h); firma prioritaria.</a:t>
+            </a:r>
+          </a:p>
+          <a:p>
+            <a:pPr>
+              <a:spcBef>
+                <a:spcPts val="400"/>
+              </a:spcBef>
+              <a:defRPr b="1" sz="900">
+                <a:solidFill>
+                  <a:srgbClr val="0F2240"/>
+                </a:solidFill>
+              </a:defRPr>
+            </a:pPr>
+            <a:r>
+              <a:t>• 🔴 Rojo (Bloqueo): </a:t>
+            </a:r>
+            <a:r>
+              <a:rPr b="0" sz="850">
+                <a:solidFill>
+                  <a:srgbClr val="0F2240"/>
+                </a:solidFill>
+              </a:rPr>
+              <a:t>Falta certificado CSS de jubilado o cédula inconsistente; devolución inmediata a sucursal.</a:t>
+            </a:r>
+          </a:p>
+          <a:p>
+            <a:pPr>
+              <a:spcBef>
+                <a:spcPts val="400"/>
+              </a:spcBef>
+              <a:defRPr b="1" sz="900">
                 <a:solidFill>
                   <a:srgbClr val="16A34A"/>
                 </a:solidFill>
@@ -8983,12 +9029,12 @@
               <a:t>Entrega: </a:t>
             </a:r>
             <a:r>
-              <a:rPr b="0" sz="900">
+              <a:rPr b="0" sz="850">
                 <a:solidFill>
                   <a:srgbClr val="0F2240"/>
                 </a:solidFill>
               </a:rPr>
-              <a:t>🟢 Expediente Certificado CDA.</a:t>
+              <a:t>Ficha de Certificación de Calidad CDA.</a:t>
             </a:r>
           </a:p>
         </p:txBody>
@@ -9001,7 +9047,7 @@
         </p:nvSpPr>
         <p:spPr>
           <a:xfrm>
-            <a:off x="685800" y="5806440"/>
+            <a:off x="685800" y="5852160"/>
             <a:ext cx="3200400" cy="411480"/>
           </a:xfrm>
           <a:prstGeom prst="roundRect">
@@ -9042,7 +9088,7 @@
               </a:defRPr>
             </a:pPr>
             <a:r>
-              <a:t>⏱️ Auditoría: De 20 min a 5 seg | Cero trabas</a:t>
+              <a:t>Semáforo: 🟢 Verde  |  🟡 Amarillo  |  🔴 Rojo</a:t>
             </a:r>
           </a:p>
         </p:txBody>
@@ -9055,7 +9101,7 @@
         </p:nvSpPr>
         <p:spPr>
           <a:xfrm>
-            <a:off x="4096512" y="3703320"/>
+            <a:off x="4096512" y="3639312"/>
             <a:ext cx="182880" cy="502920"/>
           </a:xfrm>
           <a:prstGeom prst="chevron">
@@ -9098,8 +9144,8 @@
         </p:nvSpPr>
         <p:spPr>
           <a:xfrm>
-            <a:off x="4352544" y="1691640"/>
-            <a:ext cx="3474720" cy="4663440"/>
+            <a:off x="4352544" y="1627632"/>
+            <a:ext cx="3474720" cy="4754880"/>
           </a:xfrm>
           <a:prstGeom prst="roundRect">
             <a:avLst/>
@@ -9143,7 +9189,7 @@
         </p:nvSpPr>
         <p:spPr>
           <a:xfrm>
-            <a:off x="4352544" y="1691640"/>
+            <a:off x="4352544" y="1627632"/>
             <a:ext cx="3474720" cy="502920"/>
           </a:xfrm>
           <a:prstGeom prst="rect">
@@ -9209,8 +9255,8 @@
         </p:nvSpPr>
         <p:spPr>
           <a:xfrm>
-            <a:off x="4489704" y="2286000"/>
-            <a:ext cx="3200400" cy="3474720"/>
+            <a:off x="4489704" y="2194560"/>
+            <a:ext cx="3200400" cy="3611880"/>
           </a:xfrm>
           <a:prstGeom prst="rect">
             <a:avLst/>
@@ -9224,7 +9270,7 @@
           <a:lstStyle/>
           <a:p>
             <a:pPr>
-              <a:defRPr b="1" sz="950">
+              <a:defRPr b="1" sz="900">
                 <a:solidFill>
                   <a:srgbClr val="00A4E4"/>
                 </a:solidFill>
@@ -9234,7 +9280,7 @@
               <a:t>Insumo: </a:t>
             </a:r>
             <a:r>
-              <a:rPr b="0" sz="900">
+              <a:rPr b="0" sz="850">
                 <a:solidFill>
                   <a:srgbClr val="0F2240"/>
                 </a:solidFill>
@@ -9245,9 +9291,9 @@
           <a:p>
             <a:pPr>
               <a:spcBef>
-                <a:spcPts val="500"/>
+                <a:spcPts val="400"/>
               </a:spcBef>
-              <a:defRPr b="1" sz="950">
+              <a:defRPr b="1" sz="900">
                 <a:solidFill>
                   <a:srgbClr val="00A4E4"/>
                 </a:solidFill>
@@ -9257,7 +9303,7 @@
               <a:t>Qué hace la IA: </a:t>
             </a:r>
             <a:r>
-              <a:rPr b="0" sz="900">
+              <a:rPr b="0" sz="850">
                 <a:solidFill>
                   <a:srgbClr val="0F2240"/>
                 </a:solidFill>
@@ -9268,9 +9314,9 @@
           <a:p>
             <a:pPr>
               <a:spcBef>
-                <a:spcPts val="500"/>
+                <a:spcPts val="400"/>
               </a:spcBef>
-              <a:defRPr b="1" sz="950">
+              <a:defRPr b="1" sz="900">
                 <a:solidFill>
                   <a:srgbClr val="00A4E4"/>
                 </a:solidFill>
@@ -9280,7 +9326,7 @@
               <a:t>Reconciliación: </a:t>
             </a:r>
             <a:r>
-              <a:rPr b="0" sz="900">
+              <a:rPr b="0" sz="850">
                 <a:solidFill>
                   <a:srgbClr val="0F2240"/>
                 </a:solidFill>
@@ -9291,9 +9337,9 @@
           <a:p>
             <a:pPr>
               <a:spcBef>
-                <a:spcPts val="500"/>
+                <a:spcPts val="400"/>
               </a:spcBef>
-              <a:defRPr b="1" sz="950">
+              <a:defRPr b="1" sz="900">
                 <a:solidFill>
                   <a:srgbClr val="00A4E4"/>
                 </a:solidFill>
@@ -9303,7 +9349,7 @@
               <a:t>Interacción Humana: </a:t>
             </a:r>
             <a:r>
-              <a:rPr b="0" sz="900">
+              <a:rPr b="0" sz="850">
                 <a:solidFill>
                   <a:srgbClr val="0F2240"/>
                 </a:solidFill>
@@ -9314,9 +9360,9 @@
           <a:p>
             <a:pPr>
               <a:spcBef>
-                <a:spcPts val="500"/>
+                <a:spcPts val="400"/>
               </a:spcBef>
-              <a:defRPr b="1" sz="950">
+              <a:defRPr b="1" sz="900">
                 <a:solidFill>
                   <a:srgbClr val="00A4E4"/>
                 </a:solidFill>
@@ -9326,7 +9372,7 @@
               <a:t>Impacto: </a:t>
             </a:r>
             <a:r>
-              <a:rPr b="0" sz="900">
+              <a:rPr b="0" sz="850">
                 <a:solidFill>
                   <a:srgbClr val="0F2240"/>
                 </a:solidFill>
@@ -9344,7 +9390,7 @@
         </p:nvSpPr>
         <p:spPr>
           <a:xfrm>
-            <a:off x="4489704" y="5806440"/>
+            <a:off x="4489704" y="5852160"/>
             <a:ext cx="3200400" cy="411480"/>
           </a:xfrm>
           <a:prstGeom prst="roundRect">
@@ -9385,7 +9431,7 @@
               </a:defRPr>
             </a:pPr>
             <a:r>
-              <a:t>⚡ Carga: De 10 min a 40 seg | Cero error</a:t>
+              <a:t>Smart Clipboard: De 10 min a 40 seg | Cero error</a:t>
             </a:r>
           </a:p>
         </p:txBody>
@@ -9398,7 +9444,7 @@
         </p:nvSpPr>
         <p:spPr>
           <a:xfrm>
-            <a:off x="7900416" y="3703320"/>
+            <a:off x="7900416" y="3639312"/>
             <a:ext cx="182880" cy="502920"/>
           </a:xfrm>
           <a:prstGeom prst="chevron">
@@ -9441,8 +9487,8 @@
         </p:nvSpPr>
         <p:spPr>
           <a:xfrm>
-            <a:off x="8156448" y="1691640"/>
-            <a:ext cx="3474720" cy="4663440"/>
+            <a:off x="8156448" y="1627632"/>
+            <a:ext cx="3474720" cy="4754880"/>
           </a:xfrm>
           <a:prstGeom prst="roundRect">
             <a:avLst/>
@@ -9486,7 +9532,7 @@
         </p:nvSpPr>
         <p:spPr>
           <a:xfrm>
-            <a:off x="8156448" y="1691640"/>
+            <a:off x="8156448" y="1627632"/>
             <a:ext cx="3474720" cy="502920"/>
           </a:xfrm>
           <a:prstGeom prst="rect">
@@ -9552,8 +9598,8 @@
         </p:nvSpPr>
         <p:spPr>
           <a:xfrm>
-            <a:off x="8293608" y="2286000"/>
-            <a:ext cx="3200400" cy="3474720"/>
+            <a:off x="8293608" y="2194560"/>
+            <a:ext cx="3200400" cy="3611880"/>
           </a:xfrm>
           <a:prstGeom prst="rect">
             <a:avLst/>
@@ -9567,7 +9613,7 @@
           <a:lstStyle/>
           <a:p>
             <a:pPr>
-              <a:defRPr b="1" sz="950">
+              <a:defRPr b="1" sz="900">
                 <a:solidFill>
                   <a:srgbClr val="074594"/>
                 </a:solidFill>
@@ -9577,7 +9623,7 @@
               <a:t>Insumo: </a:t>
             </a:r>
             <a:r>
-              <a:rPr b="0" sz="900">
+              <a:rPr b="0" sz="850">
                 <a:solidFill>
                   <a:srgbClr val="0F2240"/>
                 </a:solidFill>
@@ -9588,9 +9634,9 @@
           <a:p>
             <a:pPr>
               <a:spcBef>
-                <a:spcPts val="500"/>
+                <a:spcPts val="400"/>
               </a:spcBef>
-              <a:defRPr b="1" sz="950">
+              <a:defRPr b="1" sz="900">
                 <a:solidFill>
                   <a:srgbClr val="074594"/>
                 </a:solidFill>
@@ -9600,7 +9646,7 @@
               <a:t>Qué hace la IA: </a:t>
             </a:r>
             <a:r>
-              <a:rPr b="0" sz="900">
+              <a:rPr b="0" sz="850">
                 <a:solidFill>
                   <a:srgbClr val="0F2240"/>
                 </a:solidFill>
@@ -9611,9 +9657,9 @@
           <a:p>
             <a:pPr>
               <a:spcBef>
-                <a:spcPts val="500"/>
+                <a:spcPts val="400"/>
               </a:spcBef>
-              <a:defRPr b="1" sz="950">
+              <a:defRPr b="1" sz="900">
                 <a:solidFill>
                   <a:srgbClr val="074594"/>
                 </a:solidFill>
@@ -9623,7 +9669,7 @@
               <a:t>Templating Legal: </a:t>
             </a:r>
             <a:r>
-              <a:rPr b="0" sz="900">
+              <a:rPr b="0" sz="850">
                 <a:solidFill>
                   <a:srgbClr val="0F2240"/>
                 </a:solidFill>
@@ -9634,9 +9680,9 @@
           <a:p>
             <a:pPr>
               <a:spcBef>
-                <a:spcPts val="500"/>
+                <a:spcPts val="400"/>
               </a:spcBef>
-              <a:defRPr b="1" sz="950">
+              <a:defRPr b="1" sz="900">
                 <a:solidFill>
                   <a:srgbClr val="074594"/>
                 </a:solidFill>
@@ -9646,7 +9692,7 @@
               <a:t>Entrega: </a:t>
             </a:r>
             <a:r>
-              <a:rPr b="0" sz="900">
+              <a:rPr b="0" sz="850">
                 <a:solidFill>
                   <a:srgbClr val="0F2240"/>
                 </a:solidFill>
@@ -9664,7 +9710,7 @@
         </p:nvSpPr>
         <p:spPr>
           <a:xfrm>
-            <a:off x="8293608" y="5806440"/>
+            <a:off x="8293608" y="5852160"/>
             <a:ext cx="3200400" cy="411480"/>
           </a:xfrm>
           <a:prstGeom prst="roundRect">
@@ -9705,7 +9751,7 @@
               </a:defRPr>
             </a:pPr>
             <a:r>
-              <a:t>📄 Contratos: De 30 min a 15 seg en .docx</a:t>
+              <a:t>Contratos: De 30 min a 15 seg en .docx</a:t>
             </a:r>
           </a:p>
         </p:txBody>

</xml_diff>